<commit_message>
Split the monitoring figure into the three design stages
The supervisor asked for the design stages to be visible on the architecture
figure, so the canvas is now divided by dashed rules into system specification,
architectural design and detailed design, each labelled in the left margin.
</commit_message>
<xml_diff>
--- a/_work/figs/out/prometheus.pptx
+++ b/_work/figs/out/prometheus.pptx
@@ -7,7 +7,7 @@
   <p:sldIdLst>
     <p:sldId id="256" r:id="rId7"/>
   </p:sldIdLst>
-  <p:sldSz cx="12191695" cy="7486128" type="screen4x3"/>
+  <p:sldSz cx="12191695" cy="7632615" type="screen4x3"/>
   <p:notesSz cx="6858000" cy="9144000"/>
   <p:defaultTextStyle>
     <a:defPPr>
@@ -3096,12 +3096,12 @@
         </p:nvSpPr>
         <p:spPr>
           <a:xfrm>
-            <a:off x="374306" y="481251"/>
-            <a:ext cx="3475702" cy="909029"/>
+            <a:off x="1075737" y="430295"/>
+            <a:ext cx="3298929" cy="799119"/>
           </a:xfrm>
           <a:prstGeom prst="roundRect">
             <a:avLst>
-              <a:gd name="adj" fmla="val 8235"/>
+              <a:gd name="adj" fmla="val 8974"/>
             </a:avLst>
           </a:prstGeom>
           <a:solidFill>
@@ -3164,12 +3164,12 @@
         </p:nvSpPr>
         <p:spPr>
           <a:xfrm>
-            <a:off x="4331260" y="481251"/>
-            <a:ext cx="3475702" cy="909029"/>
+            <a:off x="4835697" y="430295"/>
+            <a:ext cx="3278439" cy="799119"/>
           </a:xfrm>
           <a:prstGeom prst="roundRect">
             <a:avLst>
-              <a:gd name="adj" fmla="val 8235"/>
+              <a:gd name="adj" fmla="val 8974"/>
             </a:avLst>
           </a:prstGeom>
           <a:solidFill>
@@ -3232,12 +3232,12 @@
         </p:nvSpPr>
         <p:spPr>
           <a:xfrm>
-            <a:off x="8288213" y="481251"/>
-            <a:ext cx="3529174" cy="909029"/>
+            <a:off x="8636637" y="430295"/>
+            <a:ext cx="3298929" cy="799119"/>
           </a:xfrm>
           <a:prstGeom prst="roundRect">
             <a:avLst>
-              <a:gd name="adj" fmla="val 8235"/>
+              <a:gd name="adj" fmla="val 8974"/>
             </a:avLst>
           </a:prstGeom>
           <a:solidFill>
@@ -3300,12 +3300,12 @@
         </p:nvSpPr>
         <p:spPr>
           <a:xfrm>
-            <a:off x="374306" y="1839448"/>
-            <a:ext cx="3475702" cy="855557"/>
+            <a:off x="1075737" y="1639219"/>
+            <a:ext cx="3298929" cy="778629"/>
           </a:xfrm>
           <a:prstGeom prst="roundRect">
             <a:avLst>
-              <a:gd name="adj" fmla="val 8750"/>
+              <a:gd name="adj" fmla="val 9210"/>
             </a:avLst>
           </a:prstGeom>
           <a:solidFill>
@@ -3368,12 +3368,12 @@
         </p:nvSpPr>
         <p:spPr>
           <a:xfrm>
-            <a:off x="4331260" y="1839448"/>
-            <a:ext cx="3475702" cy="855557"/>
+            <a:off x="4835697" y="1639219"/>
+            <a:ext cx="3278439" cy="778629"/>
           </a:xfrm>
           <a:prstGeom prst="roundRect">
             <a:avLst>
-              <a:gd name="adj" fmla="val 8750"/>
+              <a:gd name="adj" fmla="val 9210"/>
             </a:avLst>
           </a:prstGeom>
           <a:solidFill>
@@ -3436,12 +3436,12 @@
         </p:nvSpPr>
         <p:spPr>
           <a:xfrm>
-            <a:off x="8288213" y="1839448"/>
-            <a:ext cx="3529174" cy="855557"/>
+            <a:off x="8636637" y="1639219"/>
+            <a:ext cx="3298929" cy="778629"/>
           </a:xfrm>
           <a:prstGeom prst="roundRect">
             <a:avLst>
-              <a:gd name="adj" fmla="val 8750"/>
+              <a:gd name="adj" fmla="val 9210"/>
             </a:avLst>
           </a:prstGeom>
           <a:solidFill>
@@ -3504,12 +3504,12 @@
         </p:nvSpPr>
         <p:spPr>
           <a:xfrm>
-            <a:off x="374306" y="3154868"/>
-            <a:ext cx="11443082" cy="1732504"/>
+            <a:off x="1075737" y="2848143"/>
+            <a:ext cx="10859829" cy="1331865"/>
           </a:xfrm>
           <a:prstGeom prst="roundRect">
             <a:avLst>
-              <a:gd name="adj" fmla="val 4320"/>
+              <a:gd name="adj" fmla="val 5384"/>
             </a:avLst>
           </a:prstGeom>
           <a:solidFill>
@@ -3561,12 +3561,12 @@
         </p:nvSpPr>
         <p:spPr>
           <a:xfrm>
-            <a:off x="695140" y="3689591"/>
-            <a:ext cx="2299310" cy="876946"/>
+            <a:off x="1485542" y="3175987"/>
+            <a:ext cx="2253926" cy="778629"/>
           </a:xfrm>
           <a:prstGeom prst="roundRect">
             <a:avLst>
-              <a:gd name="adj" fmla="val 8536"/>
+              <a:gd name="adj" fmla="val 9210"/>
             </a:avLst>
           </a:prstGeom>
           <a:solidFill>
@@ -3598,7 +3598,7 @@
           <a:p>
             <a:pPr algn="ctr" rtl="1"/>
             <a:r>
-              <a:rPr sz="1000" b="0">
+              <a:rPr sz="980" b="0">
                 <a:solidFill>
                   <a:srgbClr val="1F3864"/>
                 </a:solidFill>
@@ -3610,7 +3610,7 @@
           <a:p>
             <a:pPr algn="ctr" rtl="1"/>
             <a:r>
-              <a:rPr sz="1000" b="0">
+              <a:rPr sz="980" b="0">
                 <a:solidFill>
                   <a:srgbClr val="1F3864"/>
                 </a:solidFill>
@@ -3629,12 +3629,12 @@
         </p:nvSpPr>
         <p:spPr>
           <a:xfrm>
-            <a:off x="3368757" y="3689591"/>
-            <a:ext cx="2513200" cy="876946"/>
+            <a:off x="4118539" y="3175987"/>
+            <a:ext cx="2561280" cy="778629"/>
           </a:xfrm>
           <a:prstGeom prst="roundRect">
             <a:avLst>
-              <a:gd name="adj" fmla="val 8536"/>
+              <a:gd name="adj" fmla="val 9210"/>
             </a:avLst>
           </a:prstGeom>
           <a:solidFill>
@@ -3666,7 +3666,7 @@
           <a:p>
             <a:pPr algn="ctr" rtl="1"/>
             <a:r>
-              <a:rPr sz="1000" b="0">
+              <a:rPr sz="980" b="0">
                 <a:solidFill>
                   <a:srgbClr val="1F3864"/>
                 </a:solidFill>
@@ -3678,7 +3678,7 @@
           <a:p>
             <a:pPr algn="ctr" rtl="1"/>
             <a:r>
-              <a:rPr sz="1000" b="0">
+              <a:rPr sz="980" b="0">
                 <a:solidFill>
                   <a:srgbClr val="1F3864"/>
                 </a:solidFill>
@@ -3697,12 +3697,12 @@
         </p:nvSpPr>
         <p:spPr>
           <a:xfrm>
-            <a:off x="6256264" y="3689591"/>
-            <a:ext cx="2620145" cy="876946"/>
+            <a:off x="6884721" y="3175987"/>
+            <a:ext cx="2458829" cy="778629"/>
           </a:xfrm>
           <a:prstGeom prst="roundRect">
             <a:avLst>
-              <a:gd name="adj" fmla="val 8536"/>
+              <a:gd name="adj" fmla="val 9210"/>
             </a:avLst>
           </a:prstGeom>
           <a:solidFill>
@@ -3734,7 +3734,7 @@
           <a:p>
             <a:pPr algn="ctr" rtl="1"/>
             <a:r>
-              <a:rPr sz="1000" b="0">
+              <a:rPr sz="980" b="0">
                 <a:solidFill>
                   <a:srgbClr val="1F3864"/>
                 </a:solidFill>
@@ -3746,7 +3746,7 @@
           <a:p>
             <a:pPr algn="ctr" rtl="1"/>
             <a:r>
-              <a:rPr sz="1000" b="0">
+              <a:rPr sz="980" b="0">
                 <a:solidFill>
                   <a:srgbClr val="1F3864"/>
                 </a:solidFill>
@@ -3765,12 +3765,12 @@
         </p:nvSpPr>
         <p:spPr>
           <a:xfrm>
-            <a:off x="9250716" y="3689591"/>
-            <a:ext cx="2245838" cy="876946"/>
+            <a:off x="9548453" y="3175987"/>
+            <a:ext cx="2079759" cy="778629"/>
           </a:xfrm>
           <a:prstGeom prst="roundRect">
             <a:avLst>
-              <a:gd name="adj" fmla="val 8536"/>
+              <a:gd name="adj" fmla="val 9210"/>
             </a:avLst>
           </a:prstGeom>
           <a:solidFill>
@@ -3802,7 +3802,7 @@
           <a:p>
             <a:pPr algn="ctr" rtl="1"/>
             <a:r>
-              <a:rPr sz="950" b="0">
+              <a:rPr sz="900" b="0">
                 <a:solidFill>
                   <a:srgbClr val="1F3864"/>
                 </a:solidFill>
@@ -3814,7 +3814,7 @@
           <a:p>
             <a:pPr algn="ctr" rtl="1"/>
             <a:r>
-              <a:rPr sz="950" b="0">
+              <a:rPr sz="900" b="0">
                 <a:solidFill>
                   <a:srgbClr val="1F3864"/>
                 </a:solidFill>
@@ -3833,12 +3833,12 @@
         </p:nvSpPr>
         <p:spPr>
           <a:xfrm>
-            <a:off x="588195" y="5368623"/>
-            <a:ext cx="3047923" cy="909029"/>
+            <a:off x="1075737" y="4528343"/>
+            <a:ext cx="4405402" cy="717158"/>
           </a:xfrm>
           <a:prstGeom prst="roundRect">
             <a:avLst>
-              <a:gd name="adj" fmla="val 8235"/>
+              <a:gd name="adj" fmla="val 10000"/>
             </a:avLst>
           </a:prstGeom>
           <a:solidFill>
@@ -3870,25 +3870,25 @@
           <a:p>
             <a:pPr algn="ctr" rtl="1"/>
             <a:r>
-              <a:rPr sz="950" b="0">
+              <a:rPr sz="980" b="0">
                 <a:solidFill>
                   <a:srgbClr val="1F3864"/>
                 </a:solidFill>
                 <a:latin typeface="Vazirmatn"/>
               </a:rPr>
-              <a:t>Alertmanager</a:t>
+              <a:t>Grafana</a:t>
             </a:r>
           </a:p>
           <a:p>
             <a:pPr algn="ctr" rtl="1"/>
             <a:r>
-              <a:rPr sz="950" b="0">
+              <a:rPr sz="980" b="0">
                 <a:solidFill>
                   <a:srgbClr val="1F3864"/>
                 </a:solidFill>
                 <a:latin typeface="Vazirmatn"/>
               </a:rPr>
-              <a:t>(مسیریابی و خاموش‌سازی هشدار)</a:t>
+              <a:t>(داشبورد عملیاتی)</a:t>
             </a:r>
           </a:p>
         </p:txBody>
@@ -3901,12 +3901,12 @@
         </p:nvSpPr>
         <p:spPr>
           <a:xfrm>
-            <a:off x="4010426" y="5368623"/>
-            <a:ext cx="3154868" cy="909029"/>
+            <a:off x="5890945" y="4528343"/>
+            <a:ext cx="6044621" cy="717158"/>
           </a:xfrm>
           <a:prstGeom prst="roundRect">
             <a:avLst>
-              <a:gd name="adj" fmla="val 8235"/>
+              <a:gd name="adj" fmla="val 10000"/>
             </a:avLst>
           </a:prstGeom>
           <a:solidFill>
@@ -3938,25 +3938,25 @@
           <a:p>
             <a:pPr algn="ctr" rtl="1"/>
             <a:r>
-              <a:rPr sz="1000" b="0">
+              <a:rPr sz="950" b="0">
                 <a:solidFill>
                   <a:srgbClr val="1F3864"/>
                 </a:solidFill>
                 <a:latin typeface="Vazirmatn"/>
               </a:rPr>
-              <a:t>Grafana</a:t>
+              <a:t>Alertmanager</a:t>
             </a:r>
           </a:p>
           <a:p>
             <a:pPr algn="ctr" rtl="1"/>
             <a:r>
-              <a:rPr sz="1000" b="0">
+              <a:rPr sz="950" b="0">
                 <a:solidFill>
                   <a:srgbClr val="1F3864"/>
                 </a:solidFill>
                 <a:latin typeface="Vazirmatn"/>
               </a:rPr>
-              <a:t>(داشبورد عملیاتی)</a:t>
+              <a:t>(مسیریابی و خاموش‌سازی هشدار)</a:t>
             </a:r>
           </a:p>
         </p:txBody>
@@ -3969,12 +3969,12 @@
         </p:nvSpPr>
         <p:spPr>
           <a:xfrm>
-            <a:off x="7539600" y="5293762"/>
-            <a:ext cx="4277787" cy="1048058"/>
+            <a:off x="5890945" y="5716778"/>
+            <a:ext cx="6044621" cy="973286"/>
           </a:xfrm>
           <a:prstGeom prst="roundRect">
             <a:avLst>
-              <a:gd name="adj" fmla="val 7142"/>
+              <a:gd name="adj" fmla="val 7368"/>
             </a:avLst>
           </a:prstGeom>
           <a:solidFill>
@@ -4037,12 +4037,12 @@
         </p:nvSpPr>
         <p:spPr>
           <a:xfrm>
-            <a:off x="588195" y="6577098"/>
-            <a:ext cx="11229192" cy="727223"/>
+            <a:off x="1075737" y="6915457"/>
+            <a:ext cx="10859829" cy="594217"/>
           </a:xfrm>
           <a:prstGeom prst="roundRect">
             <a:avLst>
-              <a:gd name="adj" fmla="val 10294"/>
+              <a:gd name="adj" fmla="val 12068"/>
             </a:avLst>
           </a:prstGeom>
           <a:solidFill>
@@ -4074,7 +4074,7 @@
           <a:p>
             <a:pPr algn="ctr" rtl="1"/>
             <a:r>
-              <a:rPr sz="1050" b="1">
+              <a:rPr sz="1000" b="1">
                 <a:solidFill>
                   <a:srgbClr val="1F3864"/>
                 </a:solidFill>
@@ -4093,8 +4093,8 @@
         </p:nvCxnSpPr>
         <p:spPr>
           <a:xfrm>
-            <a:off x="2112157" y="1390281"/>
-            <a:ext cx="0" cy="449167"/>
+            <a:off x="2725202" y="1229414"/>
+            <a:ext cx="0" cy="409805"/>
           </a:xfrm>
           <a:prstGeom prst="line">
             <a:avLst/>
@@ -4129,8 +4129,8 @@
         </p:nvCxnSpPr>
         <p:spPr>
           <a:xfrm>
-            <a:off x="6069111" y="1390281"/>
-            <a:ext cx="0" cy="235278"/>
+            <a:off x="6474917" y="1229414"/>
+            <a:ext cx="0" cy="102451"/>
           </a:xfrm>
           <a:prstGeom prst="line">
             <a:avLst/>
@@ -4164,8 +4164,8 @@
         </p:nvCxnSpPr>
         <p:spPr>
           <a:xfrm flipH="1">
-            <a:off x="2700353" y="1625559"/>
-            <a:ext cx="3368758" cy="0"/>
+            <a:off x="3278439" y="1331865"/>
+            <a:ext cx="3196478" cy="0"/>
           </a:xfrm>
           <a:prstGeom prst="line">
             <a:avLst/>
@@ -4199,8 +4199,8 @@
         </p:nvCxnSpPr>
         <p:spPr>
           <a:xfrm>
-            <a:off x="2700353" y="1625559"/>
-            <a:ext cx="0" cy="213889"/>
+            <a:off x="3278439" y="1331865"/>
+            <a:ext cx="0" cy="307354"/>
           </a:xfrm>
           <a:prstGeom prst="line">
             <a:avLst/>
@@ -4235,8 +4235,8 @@
         </p:nvCxnSpPr>
         <p:spPr>
           <a:xfrm>
-            <a:off x="10052801" y="1390281"/>
-            <a:ext cx="0" cy="449167"/>
+            <a:off x="10286102" y="1229414"/>
+            <a:ext cx="0" cy="409805"/>
           </a:xfrm>
           <a:prstGeom prst="line">
             <a:avLst/>
@@ -4271,8 +4271,8 @@
         </p:nvCxnSpPr>
         <p:spPr>
           <a:xfrm>
-            <a:off x="2112157" y="2695006"/>
-            <a:ext cx="0" cy="213889"/>
+            <a:off x="2725202" y="2417848"/>
+            <a:ext cx="0" cy="758139"/>
           </a:xfrm>
           <a:prstGeom prst="line">
             <a:avLst/>
@@ -4281,6 +4281,7 @@
             <a:solidFill>
               <a:srgbClr val="2F5597"/>
             </a:solidFill>
+            <a:tailEnd type="triangle" w="med" len="med"/>
           </a:ln>
         </p:spPr>
         <p:style>
@@ -4306,8 +4307,8 @@
         </p:nvCxnSpPr>
         <p:spPr>
           <a:xfrm>
-            <a:off x="2112157" y="2908895"/>
-            <a:ext cx="53473" cy="0"/>
+            <a:off x="6474917" y="2417848"/>
+            <a:ext cx="0" cy="758139"/>
           </a:xfrm>
           <a:prstGeom prst="line">
             <a:avLst/>
@@ -4316,6 +4317,8 @@
             <a:solidFill>
               <a:srgbClr val="2F5597"/>
             </a:solidFill>
+            <a:prstDash val="dash"/>
+            <a:tailEnd type="triangle" w="med" len="med"/>
           </a:ln>
         </p:spPr>
         <p:style>
@@ -4341,8 +4344,8 @@
         </p:nvCxnSpPr>
         <p:spPr>
           <a:xfrm>
-            <a:off x="2165630" y="2908895"/>
-            <a:ext cx="0" cy="780696"/>
+            <a:off x="10286102" y="2417848"/>
+            <a:ext cx="0" cy="758139"/>
           </a:xfrm>
           <a:prstGeom prst="line">
             <a:avLst/>
@@ -4377,16 +4380,17 @@
         </p:nvCxnSpPr>
         <p:spPr>
           <a:xfrm>
-            <a:off x="10052801" y="2695006"/>
-            <a:ext cx="0" cy="213889"/>
+            <a:off x="3739469" y="3565302"/>
+            <a:ext cx="379070" cy="0"/>
           </a:xfrm>
           <a:prstGeom prst="line">
             <a:avLst/>
           </a:prstGeom>
-          <a:ln w="20320">
+          <a:ln w="16510">
             <a:solidFill>
               <a:srgbClr val="2F5597"/>
             </a:solidFill>
+            <a:tailEnd type="triangle" w="med" len="med"/>
           </a:ln>
         </p:spPr>
         <p:style>
@@ -4411,17 +4415,18 @@
           <p:nvPr/>
         </p:nvCxnSpPr>
         <p:spPr>
-          <a:xfrm flipH="1">
-            <a:off x="5427443" y="2908895"/>
-            <a:ext cx="4625358" cy="0"/>
+          <a:xfrm>
+            <a:off x="6679819" y="3565302"/>
+            <a:ext cx="204902" cy="0"/>
           </a:xfrm>
           <a:prstGeom prst="line">
             <a:avLst/>
           </a:prstGeom>
-          <a:ln w="20320">
+          <a:ln w="16510">
             <a:solidFill>
               <a:srgbClr val="2F5597"/>
             </a:solidFill>
+            <a:tailEnd type="triangle" w="med" len="med"/>
           </a:ln>
         </p:spPr>
         <p:style>
@@ -4447,13 +4452,13 @@
         </p:nvCxnSpPr>
         <p:spPr>
           <a:xfrm>
-            <a:off x="5427443" y="2908895"/>
-            <a:ext cx="0" cy="780696"/>
+            <a:off x="9343551" y="3565302"/>
+            <a:ext cx="204902" cy="0"/>
           </a:xfrm>
           <a:prstGeom prst="line">
             <a:avLst/>
           </a:prstGeom>
-          <a:ln w="20320">
+          <a:ln w="16510">
             <a:solidFill>
               <a:srgbClr val="2F5597"/>
             </a:solidFill>
@@ -4483,8 +4488,8 @@
         </p:nvCxnSpPr>
         <p:spPr>
           <a:xfrm>
-            <a:off x="6069111" y="2695006"/>
-            <a:ext cx="0" cy="213889"/>
+            <a:off x="8114136" y="3954617"/>
+            <a:ext cx="0" cy="368824"/>
           </a:xfrm>
           <a:prstGeom prst="line">
             <a:avLst/>
@@ -4517,9 +4522,9 @@
           <p:nvPr/>
         </p:nvCxnSpPr>
         <p:spPr>
-          <a:xfrm>
-            <a:off x="6069111" y="2908895"/>
-            <a:ext cx="1497226" cy="0"/>
+          <a:xfrm flipH="1">
+            <a:off x="3278439" y="4323441"/>
+            <a:ext cx="4835697" cy="0"/>
           </a:xfrm>
           <a:prstGeom prst="line">
             <a:avLst/>
@@ -4553,8 +4558,8 @@
         </p:nvCxnSpPr>
         <p:spPr>
           <a:xfrm>
-            <a:off x="7566337" y="2908895"/>
-            <a:ext cx="0" cy="780696"/>
+            <a:off x="3278439" y="4323441"/>
+            <a:ext cx="0" cy="204902"/>
           </a:xfrm>
           <a:prstGeom prst="line">
             <a:avLst/>
@@ -4563,7 +4568,6 @@
             <a:solidFill>
               <a:srgbClr val="2F5597"/>
             </a:solidFill>
-            <a:prstDash val="dash"/>
             <a:tailEnd type="triangle" w="med" len="med"/>
           </a:ln>
         </p:spPr>
@@ -4590,8 +4594,8 @@
         </p:nvCxnSpPr>
         <p:spPr>
           <a:xfrm>
-            <a:off x="10373635" y="4566538"/>
-            <a:ext cx="0" cy="417084"/>
+            <a:off x="10588333" y="3954617"/>
+            <a:ext cx="0" cy="368824"/>
           </a:xfrm>
           <a:prstGeom prst="line">
             <a:avLst/>
@@ -4625,8 +4629,8 @@
         </p:nvCxnSpPr>
         <p:spPr>
           <a:xfrm flipH="1">
-            <a:off x="2112157" y="4983622"/>
-            <a:ext cx="8261478" cy="0"/>
+            <a:off x="8913256" y="4323441"/>
+            <a:ext cx="1675077" cy="0"/>
           </a:xfrm>
           <a:prstGeom prst="line">
             <a:avLst/>
@@ -4660,8 +4664,8 @@
         </p:nvCxnSpPr>
         <p:spPr>
           <a:xfrm>
-            <a:off x="2112157" y="4983622"/>
-            <a:ext cx="0" cy="385001"/>
+            <a:off x="8913256" y="4323441"/>
+            <a:ext cx="0" cy="204902"/>
           </a:xfrm>
           <a:prstGeom prst="line">
             <a:avLst/>
@@ -4696,8 +4700,8 @@
         </p:nvCxnSpPr>
         <p:spPr>
           <a:xfrm>
-            <a:off x="7192030" y="4566538"/>
-            <a:ext cx="0" cy="245973"/>
+            <a:off x="8913256" y="5245502"/>
+            <a:ext cx="0" cy="471276"/>
           </a:xfrm>
           <a:prstGeom prst="line">
             <a:avLst/>
@@ -4706,6 +4710,7 @@
             <a:solidFill>
               <a:srgbClr val="2F5597"/>
             </a:solidFill>
+            <a:tailEnd type="triangle" w="med" len="med"/>
           </a:ln>
         </p:spPr>
         <p:style>
@@ -4731,13 +4736,13 @@
         </p:nvCxnSpPr>
         <p:spPr>
           <a:xfrm flipH="1">
-            <a:off x="5587860" y="4812511"/>
-            <a:ext cx="1604170" cy="0"/>
+            <a:off x="5686042" y="6044621"/>
+            <a:ext cx="204903" cy="0"/>
           </a:xfrm>
           <a:prstGeom prst="line">
             <a:avLst/>
           </a:prstGeom>
-          <a:ln w="20320">
+          <a:ln w="17780">
             <a:solidFill>
               <a:srgbClr val="2F5597"/>
             </a:solidFill>
@@ -4765,17 +4770,18 @@
           <p:nvPr/>
         </p:nvCxnSpPr>
         <p:spPr>
-          <a:xfrm>
-            <a:off x="5587860" y="4812511"/>
-            <a:ext cx="0" cy="556112"/>
+          <a:xfrm flipV="1">
+            <a:off x="5686042" y="4180009"/>
+            <a:ext cx="0" cy="1864612"/>
           </a:xfrm>
           <a:prstGeom prst="line">
             <a:avLst/>
           </a:prstGeom>
-          <a:ln w="20320">
+          <a:ln w="17780">
             <a:solidFill>
               <a:srgbClr val="2F5597"/>
             </a:solidFill>
+            <a:prstDash val="dash"/>
             <a:tailEnd type="triangle" w="med" len="med"/>
           </a:ln>
         </p:spPr>
@@ -4802,8 +4808,8 @@
         </p:nvCxnSpPr>
         <p:spPr>
           <a:xfrm>
-            <a:off x="8154532" y="4566538"/>
-            <a:ext cx="0" cy="588196"/>
+            <a:off x="8913256" y="6690064"/>
+            <a:ext cx="0" cy="225393"/>
           </a:xfrm>
           <a:prstGeom prst="line">
             <a:avLst/>
@@ -4812,6 +4818,7 @@
             <a:solidFill>
               <a:srgbClr val="2F5597"/>
             </a:solidFill>
+            <a:tailEnd type="triangle" w="med" len="med"/>
           </a:ln>
         </p:spPr>
         <p:style>
@@ -4836,14 +4843,14 @@
           <p:nvPr/>
         </p:nvCxnSpPr>
         <p:spPr>
-          <a:xfrm>
-            <a:off x="8154532" y="5154734"/>
-            <a:ext cx="1523962" cy="0"/>
+          <a:xfrm flipH="1">
+            <a:off x="881080" y="7212565"/>
+            <a:ext cx="194657" cy="0"/>
           </a:xfrm>
           <a:prstGeom prst="line">
             <a:avLst/>
           </a:prstGeom>
-          <a:ln w="20320">
+          <a:ln w="17780">
             <a:solidFill>
               <a:srgbClr val="2F5597"/>
             </a:solidFill>
@@ -4871,18 +4878,17 @@
           <p:nvPr/>
         </p:nvCxnSpPr>
         <p:spPr>
-          <a:xfrm>
-            <a:off x="9678494" y="5154734"/>
-            <a:ext cx="0" cy="139028"/>
+          <a:xfrm flipV="1">
+            <a:off x="881080" y="829854"/>
+            <a:ext cx="0" cy="6382711"/>
           </a:xfrm>
           <a:prstGeom prst="line">
             <a:avLst/>
           </a:prstGeom>
-          <a:ln w="20320">
+          <a:ln w="17780">
             <a:solidFill>
               <a:srgbClr val="2F5597"/>
             </a:solidFill>
-            <a:tailEnd type="triangle" w="med" len="med"/>
           </a:ln>
         </p:spPr>
         <p:style>
@@ -4908,8 +4914,8 @@
         </p:nvCxnSpPr>
         <p:spPr>
           <a:xfrm>
-            <a:off x="2112157" y="6277653"/>
-            <a:ext cx="0" cy="181806"/>
+            <a:off x="881080" y="829854"/>
+            <a:ext cx="194657" cy="0"/>
           </a:xfrm>
           <a:prstGeom prst="line">
             <a:avLst/>
@@ -4918,6 +4924,8 @@
             <a:solidFill>
               <a:srgbClr val="2F5597"/>
             </a:solidFill>
+            <a:prstDash val="dash"/>
+            <a:tailEnd type="triangle" w="med" len="med"/>
           </a:ln>
         </p:spPr>
         <p:style>
@@ -4943,16 +4951,17 @@
         </p:nvCxnSpPr>
         <p:spPr>
           <a:xfrm>
-            <a:off x="2112157" y="6459459"/>
-            <a:ext cx="6336473" cy="0"/>
+            <a:off x="143431" y="1475297"/>
+            <a:ext cx="11904832" cy="0"/>
           </a:xfrm>
           <a:prstGeom prst="line">
             <a:avLst/>
           </a:prstGeom>
-          <a:ln w="17780">
+          <a:ln w="13970">
             <a:solidFill>
-              <a:srgbClr val="2F5597"/>
+              <a:srgbClr val="8C8C8C"/>
             </a:solidFill>
+            <a:prstDash val="dash"/>
           </a:ln>
         </p:spPr>
         <p:style>
@@ -4977,18 +4986,18 @@
           <p:nvPr/>
         </p:nvCxnSpPr>
         <p:spPr>
-          <a:xfrm flipV="1">
-            <a:off x="8448630" y="6341820"/>
-            <a:ext cx="0" cy="117639"/>
+          <a:xfrm>
+            <a:off x="143431" y="5368443"/>
+            <a:ext cx="11904832" cy="0"/>
           </a:xfrm>
           <a:prstGeom prst="line">
             <a:avLst/>
           </a:prstGeom>
-          <a:ln w="17780">
+          <a:ln w="13970">
             <a:solidFill>
-              <a:srgbClr val="2F5597"/>
+              <a:srgbClr val="8C8C8C"/>
             </a:solidFill>
-            <a:tailEnd type="triangle" w="med" len="med"/>
+            <a:prstDash val="dash"/>
           </a:ln>
         </p:spPr>
         <p:style>
@@ -5006,159 +5015,16 @@
           </a:fontRef>
         </p:style>
       </p:cxnSp>
-      <p:cxnSp>
-        <p:nvCxnSpPr>
-          <p:cNvPr id="43" name="Connector 42"/>
-          <p:cNvCxnSpPr/>
-          <p:nvPr/>
-        </p:nvCxnSpPr>
-        <p:spPr>
-          <a:xfrm>
-            <a:off x="9678494" y="6341820"/>
-            <a:ext cx="0" cy="235278"/>
-          </a:xfrm>
-          <a:prstGeom prst="line">
-            <a:avLst/>
-          </a:prstGeom>
-          <a:ln w="20320">
-            <a:solidFill>
-              <a:srgbClr val="2F5597"/>
-            </a:solidFill>
-            <a:tailEnd type="triangle" w="med" len="med"/>
-          </a:ln>
-        </p:spPr>
-        <p:style>
-          <a:lnRef idx="2">
-            <a:schemeClr val="accent1"/>
-          </a:lnRef>
-          <a:fillRef idx="0">
-            <a:schemeClr val="accent1"/>
-          </a:fillRef>
-          <a:effectRef idx="1">
-            <a:schemeClr val="accent1"/>
-          </a:effectRef>
-          <a:fontRef idx="minor">
-            <a:schemeClr val="tx1"/>
-          </a:fontRef>
-        </p:style>
-      </p:cxnSp>
-      <p:cxnSp>
-        <p:nvCxnSpPr>
-          <p:cNvPr id="44" name="Connector 43"/>
-          <p:cNvCxnSpPr/>
-          <p:nvPr/>
-        </p:nvCxnSpPr>
-        <p:spPr>
-          <a:xfrm flipH="1">
-            <a:off x="128333" y="6940710"/>
-            <a:ext cx="459862" cy="0"/>
-          </a:xfrm>
-          <a:prstGeom prst="line">
-            <a:avLst/>
-          </a:prstGeom>
-          <a:ln w="20320">
-            <a:solidFill>
-              <a:srgbClr val="2F5597"/>
-            </a:solidFill>
-          </a:ln>
-        </p:spPr>
-        <p:style>
-          <a:lnRef idx="2">
-            <a:schemeClr val="accent1"/>
-          </a:lnRef>
-          <a:fillRef idx="0">
-            <a:schemeClr val="accent1"/>
-          </a:fillRef>
-          <a:effectRef idx="1">
-            <a:schemeClr val="accent1"/>
-          </a:effectRef>
-          <a:fontRef idx="minor">
-            <a:schemeClr val="tx1"/>
-          </a:fontRef>
-        </p:style>
-      </p:cxnSp>
-      <p:cxnSp>
-        <p:nvCxnSpPr>
-          <p:cNvPr id="45" name="Connector 44"/>
-          <p:cNvCxnSpPr/>
-          <p:nvPr/>
-        </p:nvCxnSpPr>
-        <p:spPr>
-          <a:xfrm flipV="1">
-            <a:off x="128333" y="935766"/>
-            <a:ext cx="0" cy="6004944"/>
-          </a:xfrm>
-          <a:prstGeom prst="line">
-            <a:avLst/>
-          </a:prstGeom>
-          <a:ln w="20320">
-            <a:solidFill>
-              <a:srgbClr val="2F5597"/>
-            </a:solidFill>
-          </a:ln>
-        </p:spPr>
-        <p:style>
-          <a:lnRef idx="2">
-            <a:schemeClr val="accent1"/>
-          </a:lnRef>
-          <a:fillRef idx="0">
-            <a:schemeClr val="accent1"/>
-          </a:fillRef>
-          <a:effectRef idx="1">
-            <a:schemeClr val="accent1"/>
-          </a:effectRef>
-          <a:fontRef idx="minor">
-            <a:schemeClr val="tx1"/>
-          </a:fontRef>
-        </p:style>
-      </p:cxnSp>
-      <p:cxnSp>
-        <p:nvCxnSpPr>
-          <p:cNvPr id="46" name="Connector 45"/>
-          <p:cNvCxnSpPr/>
-          <p:nvPr/>
-        </p:nvCxnSpPr>
-        <p:spPr>
-          <a:xfrm>
-            <a:off x="128333" y="935766"/>
-            <a:ext cx="245973" cy="0"/>
-          </a:xfrm>
-          <a:prstGeom prst="line">
-            <a:avLst/>
-          </a:prstGeom>
-          <a:ln w="20320">
-            <a:solidFill>
-              <a:srgbClr val="2F5597"/>
-            </a:solidFill>
-            <a:prstDash val="dash"/>
-            <a:tailEnd type="triangle" w="med" len="med"/>
-          </a:ln>
-        </p:spPr>
-        <p:style>
-          <a:lnRef idx="2">
-            <a:schemeClr val="accent1"/>
-          </a:lnRef>
-          <a:fillRef idx="0">
-            <a:schemeClr val="accent1"/>
-          </a:fillRef>
-          <a:effectRef idx="1">
-            <a:schemeClr val="accent1"/>
-          </a:effectRef>
-          <a:fontRef idx="minor">
-            <a:schemeClr val="tx1"/>
-          </a:fontRef>
-        </p:style>
-      </p:cxnSp>
-      <p:sp>
-        <p:nvSpPr>
-          <p:cNvPr id="47" name="TextBox 46"/>
+      <p:sp>
+        <p:nvSpPr>
+          <p:cNvPr id="43" name="TextBox 42"/>
           <p:cNvSpPr txBox="1"/>
           <p:nvPr/>
         </p:nvSpPr>
         <p:spPr>
-          <a:xfrm>
-            <a:off x="5561124" y="3165562"/>
-            <a:ext cx="1069446" cy="427778"/>
+          <a:xfrm rot="16200000">
+            <a:off x="-425172" y="665932"/>
+            <a:ext cx="1792896" cy="430295"/>
           </a:xfrm>
           <a:prstGeom prst="rect">
             <a:avLst/>
@@ -5173,27 +5039,39 @@
           <a:p>
             <a:pPr algn="ctr"/>
             <a:r>
-              <a:rPr sz="1100" b="1">
+              <a:rPr sz="919" b="1">
                 <a:solidFill>
                   <a:srgbClr val="1F3864"/>
                 </a:solidFill>
                 <a:latin typeface="Vazirmatn"/>
               </a:rPr>
-              <a:t>سرور پرومتئوس (Prometheus Server)</a:t>
-            </a:r>
-          </a:p>
-        </p:txBody>
-      </p:sp>
-      <p:sp>
-        <p:nvSpPr>
-          <p:cNvPr id="48" name="TextBox 47"/>
+              <a:t>۱.</a:t>
+            </a:r>
+          </a:p>
+          <a:p>
+            <a:pPr algn="ctr"/>
+            <a:r>
+              <a:rPr sz="919" b="1">
+                <a:solidFill>
+                  <a:srgbClr val="1F3864"/>
+                </a:solidFill>
+                <a:latin typeface="Vazirmatn"/>
+              </a:rPr>
+              <a:t>مشخصات سامانه</a:t>
+            </a:r>
+          </a:p>
+        </p:txBody>
+      </p:sp>
+      <p:sp>
+        <p:nvSpPr>
+          <p:cNvPr id="44" name="TextBox 43"/>
           <p:cNvSpPr txBox="1"/>
           <p:nvPr/>
         </p:nvSpPr>
         <p:spPr>
-          <a:xfrm>
-            <a:off x="4331260" y="2844728"/>
-            <a:ext cx="1069446" cy="427778"/>
+          <a:xfrm rot="16200000">
+            <a:off x="-425172" y="3165742"/>
+            <a:ext cx="1792896" cy="430295"/>
           </a:xfrm>
           <a:prstGeom prst="rect">
             <a:avLst/>
@@ -5208,27 +5086,39 @@
           <a:p>
             <a:pPr algn="ctr"/>
             <a:r>
-              <a:rPr sz="950" b="0">
-                <a:solidFill>
-                  <a:srgbClr val="2F5597"/>
+              <a:rPr sz="919" b="1">
+                <a:solidFill>
+                  <a:srgbClr val="1F3864"/>
                 </a:solidFill>
                 <a:latin typeface="Vazirmatn"/>
               </a:rPr>
-              <a:t>remote write</a:t>
-            </a:r>
-          </a:p>
-        </p:txBody>
-      </p:sp>
-      <p:sp>
-        <p:nvSpPr>
-          <p:cNvPr id="49" name="TextBox 48"/>
+              <a:t>۲.</a:t>
+            </a:r>
+          </a:p>
+          <a:p>
+            <a:pPr algn="ctr"/>
+            <a:r>
+              <a:rPr sz="919" b="1">
+                <a:solidFill>
+                  <a:srgbClr val="1F3864"/>
+                </a:solidFill>
+                <a:latin typeface="Vazirmatn"/>
+              </a:rPr>
+              <a:t>طراحی معماری</a:t>
+            </a:r>
+          </a:p>
+        </p:txBody>
+      </p:sp>
+      <p:sp>
+        <p:nvSpPr>
+          <p:cNvPr id="45" name="TextBox 44"/>
           <p:cNvSpPr txBox="1"/>
           <p:nvPr/>
         </p:nvSpPr>
         <p:spPr>
-          <a:xfrm>
-            <a:off x="128333" y="4983622"/>
-            <a:ext cx="1069446" cy="427778"/>
+          <a:xfrm rot="16200000">
+            <a:off x="-425172" y="6280259"/>
+            <a:ext cx="1792896" cy="430295"/>
           </a:xfrm>
           <a:prstGeom prst="rect">
             <a:avLst/>
@@ -5243,27 +5133,39 @@
           <a:p>
             <a:pPr algn="ctr"/>
             <a:r>
-              <a:rPr sz="950" b="0">
-                <a:solidFill>
-                  <a:srgbClr val="2F5597"/>
+              <a:rPr sz="919" b="1">
+                <a:solidFill>
+                  <a:srgbClr val="1F3864"/>
                 </a:solidFill>
                 <a:latin typeface="Vazirmatn"/>
               </a:rPr>
-              <a:t>بازخورد</a:t>
-            </a:r>
-          </a:p>
-        </p:txBody>
-      </p:sp>
-      <p:sp>
-        <p:nvSpPr>
-          <p:cNvPr id="50" name="TextBox 49"/>
+              <a:t>۳.</a:t>
+            </a:r>
+          </a:p>
+          <a:p>
+            <a:pPr algn="ctr"/>
+            <a:r>
+              <a:rPr sz="919" b="1">
+                <a:solidFill>
+                  <a:srgbClr val="1F3864"/>
+                </a:solidFill>
+                <a:latin typeface="Vazirmatn"/>
+              </a:rPr>
+              <a:t>طراحی تفصیلی</a:t>
+            </a:r>
+          </a:p>
+        </p:txBody>
+      </p:sp>
+      <p:sp>
+        <p:nvSpPr>
+          <p:cNvPr id="46" name="TextBox 45"/>
           <p:cNvSpPr txBox="1"/>
           <p:nvPr/>
         </p:nvSpPr>
         <p:spPr>
           <a:xfrm>
-            <a:off x="9753356" y="6234875"/>
-            <a:ext cx="1069446" cy="427778"/>
+            <a:off x="5993396" y="2796918"/>
+            <a:ext cx="1024512" cy="409804"/>
           </a:xfrm>
           <a:prstGeom prst="rect">
             <a:avLst/>
@@ -5278,13 +5180,118 @@
           <a:p>
             <a:pPr algn="ctr"/>
             <a:r>
-              <a:rPr sz="950" b="0">
+              <a:rPr sz="1100" b="1">
                 <a:solidFill>
                   <a:srgbClr val="2F5597"/>
                 </a:solidFill>
                 <a:latin typeface="Vazirmatn"/>
               </a:rPr>
-              <a:t>تصمیم</a:t>
+              <a:t>سرور پرومتئوس (Prometheus Server)</a:t>
+            </a:r>
+          </a:p>
+        </p:txBody>
+      </p:sp>
+      <p:sp>
+        <p:nvSpPr>
+          <p:cNvPr id="47" name="TextBox 46"/>
+          <p:cNvSpPr txBox="1"/>
+          <p:nvPr/>
+        </p:nvSpPr>
+        <p:spPr>
+          <a:xfrm>
+            <a:off x="6864231" y="2417848"/>
+            <a:ext cx="1024512" cy="409804"/>
+          </a:xfrm>
+          <a:prstGeom prst="rect">
+            <a:avLst/>
+          </a:prstGeom>
+          <a:noFill/>
+        </p:spPr>
+        <p:txBody>
+          <a:bodyPr wrap="none">
+            <a:spAutoFit/>
+          </a:bodyPr>
+          <a:lstStyle/>
+          <a:p>
+            <a:pPr algn="ctr"/>
+            <a:r>
+              <a:rPr sz="850" b="0">
+                <a:solidFill>
+                  <a:srgbClr val="2F5597"/>
+                </a:solidFill>
+                <a:latin typeface="Vazirmatn"/>
+              </a:rPr>
+              <a:t>remote write</a:t>
+            </a:r>
+          </a:p>
+        </p:txBody>
+      </p:sp>
+      <p:sp>
+        <p:nvSpPr>
+          <p:cNvPr id="48" name="TextBox 47"/>
+          <p:cNvSpPr txBox="1"/>
+          <p:nvPr/>
+        </p:nvSpPr>
+        <p:spPr>
+          <a:xfrm>
+            <a:off x="7735067" y="5286482"/>
+            <a:ext cx="1024512" cy="409804"/>
+          </a:xfrm>
+          <a:prstGeom prst="rect">
+            <a:avLst/>
+          </a:prstGeom>
+          <a:noFill/>
+        </p:spPr>
+        <p:txBody>
+          <a:bodyPr wrap="none">
+            <a:spAutoFit/>
+          </a:bodyPr>
+          <a:lstStyle/>
+          <a:p>
+            <a:pPr algn="ctr"/>
+            <a:r>
+              <a:rPr sz="880" b="0">
+                <a:solidFill>
+                  <a:srgbClr val="2F5597"/>
+                </a:solidFill>
+                <a:latin typeface="Vazirmatn"/>
+              </a:rPr>
+              <a:t>هشدار</a:t>
+            </a:r>
+          </a:p>
+        </p:txBody>
+      </p:sp>
+      <p:sp>
+        <p:nvSpPr>
+          <p:cNvPr id="49" name="TextBox 48"/>
+          <p:cNvSpPr txBox="1"/>
+          <p:nvPr/>
+        </p:nvSpPr>
+        <p:spPr>
+          <a:xfrm rot="16200000">
+            <a:off x="-251005" y="1936328"/>
+            <a:ext cx="1792896" cy="430295"/>
+          </a:xfrm>
+          <a:prstGeom prst="rect">
+            <a:avLst/>
+          </a:prstGeom>
+          <a:noFill/>
+        </p:spPr>
+        <p:txBody>
+          <a:bodyPr wrap="none">
+            <a:spAutoFit/>
+          </a:bodyPr>
+          <a:lstStyle/>
+          <a:p>
+            <a:pPr algn="ctr"/>
+            <a:r>
+              <a:rPr sz="860" b="0">
+                <a:solidFill>
+                  <a:srgbClr val="2F5597"/>
+                </a:solidFill>
+                <a:latin typeface="Vazirmatn"/>
+              </a:rPr>
+              <a:t>بازخورد</a:t>
             </a:r>
           </a:p>
         </p:txBody>

</xml_diff>